<commit_message>
feat: update PPT to 23 slides with detailed GitHub publishing steps and masked PAT security
</commit_message>
<xml_diff>
--- a/第一場_Antigravity代理AI教學實戰_大字動畫版_GitHub發布版.pptx
+++ b/第一場_Antigravity代理AI教學實戰_大字動畫版_GitHub發布版.pptx
@@ -27,6 +27,7 @@
     <p:sldId id="275" r:id="rId27"/>
     <p:sldId id="276" r:id="rId28"/>
     <p:sldId id="277" r:id="rId29"/>
+    <p:sldId id="278" r:id="rId30"/>
   </p:sldIdLst>
   <p:sldSz cx="12191695" cy="6858000" type="screen4x3"/>
   <p:notesSz cx="6858000" cy="9144000"/>
@@ -3983,7 +3984,7 @@
               </a:defRPr>
             </a:pPr>
             <a:r>
-              <a:t>第 10 / 22 頁</a:t>
+              <a:t>第 10 / 23 頁</a:t>
             </a:r>
           </a:p>
         </p:txBody>
@@ -4569,7 +4570,7 @@
               </a:defRPr>
             </a:pPr>
             <a:r>
-              <a:t>第 11 / 22 頁</a:t>
+              <a:t>第 11 / 23 頁</a:t>
             </a:r>
           </a:p>
         </p:txBody>
@@ -5210,7 +5211,7 @@
               </a:defRPr>
             </a:pPr>
             <a:r>
-              <a:t>第 12 / 22 頁</a:t>
+              <a:t>第 12 / 23 頁</a:t>
             </a:r>
           </a:p>
         </p:txBody>
@@ -5802,7 +5803,7 @@
               </a:defRPr>
             </a:pPr>
             <a:r>
-              <a:t>第 13 / 22 頁</a:t>
+              <a:t>第 13 / 23 頁</a:t>
             </a:r>
           </a:p>
         </p:txBody>
@@ -6476,7 +6477,7 @@
               </a:defRPr>
             </a:pPr>
             <a:r>
-              <a:t>第 14 / 22 頁</a:t>
+              <a:t>第 14 / 23 頁</a:t>
             </a:r>
           </a:p>
         </p:txBody>
@@ -7184,7 +7185,7 @@
               </a:defRPr>
             </a:pPr>
             <a:r>
-              <a:t>第 15 / 22 頁</a:t>
+              <a:t>第 15 / 23 頁</a:t>
             </a:r>
           </a:p>
         </p:txBody>
@@ -7907,7 +7908,7 @@
               </a:defRPr>
             </a:pPr>
             <a:r>
-              <a:t>第 16 / 22 頁</a:t>
+              <a:t>第 16 / 23 頁</a:t>
             </a:r>
           </a:p>
         </p:txBody>
@@ -8666,7 +8667,7 @@
               </a:defRPr>
             </a:pPr>
             <a:r>
-              <a:t>第 17 / 22 頁</a:t>
+              <a:t>第 17 / 23 頁</a:t>
             </a:r>
           </a:p>
         </p:txBody>
@@ -9220,7 +9221,7 @@
               </a:defRPr>
             </a:pPr>
             <a:r>
-              <a:t>第 18 / 22 頁</a:t>
+              <a:t>第 18 / 23 頁</a:t>
             </a:r>
           </a:p>
         </p:txBody>
@@ -10847,7 +10848,7 @@
               </a:defRPr>
             </a:pPr>
             <a:r>
-              <a:t>第 19 / 22 頁</a:t>
+              <a:t>第 19 / 23 頁</a:t>
             </a:r>
           </a:p>
         </p:txBody>
@@ -11358,7 +11359,7 @@
               </a:defRPr>
             </a:pPr>
             <a:r>
-              <a:t>第 02 / 22 頁</a:t>
+              <a:t>第 02 / 23 頁</a:t>
             </a:r>
           </a:p>
         </p:txBody>
@@ -12252,7 +12253,7 @@
               </a:defRPr>
             </a:pPr>
             <a:r>
-              <a:t>第 20 / 22 頁</a:t>
+              <a:t>第 20 / 23 頁</a:t>
             </a:r>
           </a:p>
         </p:txBody>
@@ -12288,7 +12289,7 @@
               </a:defRPr>
             </a:pPr>
             <a:r>
-              <a:t>成果發布 01：GitHub 免費帳號註冊與個人網址規劃</a:t>
+              <a:t>成果發布 01：免費帳號開立 ✕ 建立專屬倉庫 (www)</a:t>
             </a:r>
           </a:p>
         </p:txBody>
@@ -12362,7 +12363,7 @@
           <a:p>
             <a:pPr>
               <a:spcAft>
-                <a:spcPts val="1200"/>
+                <a:spcPts val="1000"/>
               </a:spcAft>
               <a:defRPr sz="2000" b="1">
                 <a:solidFill>
@@ -12372,7 +12373,7 @@
               </a:defRPr>
             </a:pPr>
             <a:r>
-              <a:t>📝 3 分鐘免費註冊步驟（按圖索驥）</a:t>
+              <a:t>📝 步驟一：註冊個人 GitHub 帳號</a:t>
             </a:r>
           </a:p>
           <a:p>
@@ -12385,13 +12386,13 @@
               </a:defRPr>
             </a:pPr>
             <a:r>
-              <a:t>步驟 1：前往官方網站</a:t>
+              <a:t>1. 前往官網</a:t>
             </a:r>
           </a:p>
           <a:p>
             <a:pPr>
               <a:spcAft>
-                <a:spcPts val="800"/>
+                <a:spcPts val="600"/>
               </a:spcAft>
               <a:defRPr sz="1300">
                 <a:solidFill>
@@ -12401,7 +12402,7 @@
               </a:defRPr>
             </a:pPr>
             <a:r>
-              <a:t>打開瀏覽器連至 github.com，點右上角「Sign up」綠色註冊鈕。</a:t>
+              <a:t>瀏覽器打開 github.com，點右上角綠色「Sign up」。</a:t>
             </a:r>
           </a:p>
           <a:p>
@@ -12414,13 +12415,13 @@
               </a:defRPr>
             </a:pPr>
             <a:r>
-              <a:t>步驟 2：填寫基本三要素</a:t>
+              <a:t>2. 填寫三要素</a:t>
             </a:r>
           </a:p>
           <a:p>
             <a:pPr>
               <a:spcAft>
-                <a:spcPts val="800"/>
+                <a:spcPts val="600"/>
               </a:spcAft>
               <a:defRPr sz="1300">
                 <a:solidFill>
@@ -12430,7 +12431,7 @@
               </a:defRPr>
             </a:pPr>
             <a:r>
-              <a:t>輸入 Email（收驗證碼）➔ 設定高強度密碼 ➔ 決定 Username。</a:t>
+              <a:t>輸入信箱（收驗證碼）➔ 設定高強度密碼 ➔ 決定 Username。</a:t>
             </a:r>
           </a:p>
           <a:p>
@@ -12443,13 +12444,13 @@
               </a:defRPr>
             </a:pPr>
             <a:r>
-              <a:t>⭐ 帳號命名關鍵訣竅</a:t>
+              <a:t>⭐ 命名即網址！</a:t>
             </a:r>
           </a:p>
           <a:p>
             <a:pPr>
               <a:spcAft>
-                <a:spcPts val="800"/>
+                <a:spcPts val="600"/>
               </a:spcAft>
               <a:defRPr sz="1300">
                 <a:solidFill>
@@ -12459,7 +12460,7 @@
               </a:defRPr>
             </a:pPr>
             <a:r>
-              <a:t>Username 將成為個人教學網站網址！例如 teacher-lin，日後網址即為 teacher-lin.github.io。</a:t>
+              <a:t>Username 會直接變成個人教學網站網址！例如簡老師為 stj580508，日後專屬站點即為 stj580508.github.io。</a:t>
             </a:r>
           </a:p>
           <a:p>
@@ -12472,13 +12473,13 @@
               </a:defRPr>
             </a:pPr>
             <a:r>
-              <a:t>步驟 3：防偽驗證與啟用</a:t>
+              <a:t>3. 驗證啟用</a:t>
             </a:r>
           </a:p>
           <a:p>
             <a:pPr>
               <a:spcAft>
-                <a:spcPts val="800"/>
+                <a:spcPts val="600"/>
               </a:spcAft>
               <a:defRPr sz="1300">
                 <a:solidFill>
@@ -12488,7 +12489,7 @@
               </a:defRPr>
             </a:pPr>
             <a:r>
-              <a:t>完成拼圖或動物方向旋轉驗證，至信箱收 8 位數驗證碼回填即可！</a:t>
+              <a:t>完成動物旋轉拼圖防偽驗證，收信填 8 位數驗證碼即可！</a:t>
             </a:r>
           </a:p>
         </p:txBody>
@@ -12562,7 +12563,7 @@
           <a:p>
             <a:pPr>
               <a:spcAft>
-                <a:spcPts val="1200"/>
+                <a:spcPts val="1000"/>
               </a:spcAft>
               <a:defRPr sz="2000" b="1">
                 <a:solidFill>
@@ -12572,7 +12573,7 @@
               </a:defRPr>
             </a:pPr>
             <a:r>
-              <a:t>💡 老師為什麼需要 GitHub？</a:t>
+              <a:t>📂 步驟二：建立名為 www 的儲存庫</a:t>
             </a:r>
           </a:p>
           <a:p>
@@ -12585,13 +12586,13 @@
               </a:defRPr>
             </a:pPr>
             <a:r>
-              <a:t>🌐 終身免費靜態網頁託管 (GitHub Pages)</a:t>
+              <a:t>1. 點擊右上角「+」號</a:t>
             </a:r>
           </a:p>
           <a:p>
             <a:pPr>
               <a:spcAft>
-                <a:spcPts val="800"/>
+                <a:spcPts val="600"/>
               </a:spcAft>
               <a:defRPr sz="1300">
                 <a:solidFill>
@@ -12601,7 +12602,7 @@
               </a:defRPr>
             </a:pPr>
             <a:r>
-              <a:t>不需花錢租伺服器，教材、學習單放上去自動生成永久專屬網址。</a:t>
+              <a:t>在 GitHub 畫面右上角點選「New repository」。</a:t>
             </a:r>
           </a:p>
           <a:p>
@@ -12614,13 +12615,13 @@
               </a:defRPr>
             </a:pPr>
             <a:r>
-              <a:t>📱 手機、平板、電腦隨點隨看</a:t>
+              <a:t>2. 倉庫名稱填寫 www</a:t>
             </a:r>
           </a:p>
           <a:p>
             <a:pPr>
               <a:spcAft>
-                <a:spcPts val="800"/>
+                <a:spcPts val="600"/>
               </a:spcAft>
               <a:defRPr sz="1300">
                 <a:solidFill>
@@ -12630,7 +12631,7 @@
               </a:defRPr>
             </a:pPr>
             <a:r>
-              <a:t>學生或觀課老師掃描 QR Code 就能即時瀏覽互動題目與電路圖。</a:t>
+              <a:t>Repository name 輸入 www，代表個人教學首頁根目錄。</a:t>
             </a:r>
           </a:p>
           <a:p>
@@ -12643,13 +12644,13 @@
               </a:defRPr>
             </a:pPr>
             <a:r>
-              <a:t>🛡️ 雲端永久備份與版本履歷</a:t>
+              <a:t>3. 務必勾選 Public（公開）</a:t>
             </a:r>
           </a:p>
           <a:p>
             <a:pPr>
               <a:spcAft>
-                <a:spcPts val="800"/>
+                <a:spcPts val="600"/>
               </a:spcAft>
               <a:defRPr sz="1300">
                 <a:solidFill>
@@ -12659,7 +12660,7 @@
               </a:defRPr>
             </a:pPr>
             <a:r>
-              <a:t>每次修改教材都有歷史紀錄，不怕誤刪或檔案毀損。</a:t>
+              <a:t>勾選 Public，其餘 README、.gitignore 保持預設空白免勾。</a:t>
             </a:r>
           </a:p>
           <a:p>
@@ -12672,13 +12673,13 @@
               </a:defRPr>
             </a:pPr>
             <a:r>
-              <a:t>🤖 代理 AI 接管重活</a:t>
+              <a:t>4. 點綠色按鈕建立</a:t>
             </a:r>
           </a:p>
           <a:p>
             <a:pPr>
               <a:spcAft>
-                <a:spcPts val="800"/>
+                <a:spcPts val="600"/>
               </a:spcAft>
               <a:defRPr sz="1300">
                 <a:solidFill>
@@ -12688,7 +12689,7 @@
               </a:defRPr>
             </a:pPr>
             <a:r>
-              <a:t>老師不必學複雜 Git 指令，只要動動嘴，編碼與推送全由代理人搞定！</a:t>
+              <a:t>按下「Create repository」，取得網址：github.com/stj580508/www。</a:t>
             </a:r>
           </a:p>
         </p:txBody>
@@ -12910,7 +12911,7 @@
               </a:defRPr>
             </a:pPr>
             <a:r>
-              <a:t>第 21 / 22 頁</a:t>
+              <a:t>第 21 / 23 頁</a:t>
             </a:r>
           </a:p>
         </p:txBody>
@@ -12946,7 +12947,7 @@
               </a:defRPr>
             </a:pPr>
             <a:r>
-              <a:t>成果發布 02：建立倉庫 ✕ 代理人一鍵轉網頁推播 (Prompt 06)</a:t>
+              <a:t>成果發布 02：產生個人安全金鑰 (Personal Access Token)</a:t>
             </a:r>
           </a:p>
         </p:txBody>
@@ -13020,38 +13021,38 @@
           <a:p>
             <a:pPr>
               <a:spcAft>
-                <a:spcPts val="1200"/>
-              </a:spcAft>
-              <a:defRPr sz="2000" b="1">
-                <a:solidFill>
-                  <a:srgbClr val="1F4435"/>
-                </a:solidFill>
-                <a:latin typeface="微軟正黑體"/>
-              </a:defRPr>
-            </a:pPr>
-            <a:r>
-              <a:t>🖱️ 老師只需做這一步：開新倉庫</a:t>
-            </a:r>
-          </a:p>
-          <a:p>
-            <a:pPr>
-              <a:defRPr sz="1500" b="1">
-                <a:solidFill>
-                  <a:srgbClr val="1F4435"/>
-                </a:solidFill>
-                <a:latin typeface="微軟正黑體"/>
-              </a:defRPr>
-            </a:pPr>
-            <a:r>
-              <a:t>1. 點擊右上角「+」號</a:t>
-            </a:r>
-          </a:p>
-          <a:p>
-            <a:pPr>
-              <a:spcAft>
                 <a:spcPts val="800"/>
               </a:spcAft>
-              <a:defRPr sz="1300">
+              <a:defRPr sz="1900" b="1">
+                <a:solidFill>
+                  <a:srgbClr val="1F4435"/>
+                </a:solidFill>
+                <a:latin typeface="微軟正黑體"/>
+              </a:defRPr>
+            </a:pPr>
+            <a:r>
+              <a:t>🔑 步驟三：為什麼不能用登入密碼？</a:t>
+            </a:r>
+          </a:p>
+          <a:p>
+            <a:pPr>
+              <a:defRPr sz="1400" b="1">
+                <a:solidFill>
+                  <a:srgbClr val="1F4435"/>
+                </a:solidFill>
+                <a:latin typeface="微軟正黑體"/>
+              </a:defRPr>
+            </a:pPr>
+            <a:r>
+              <a:t>🛡️ GitHub 資安規範升級</a:t>
+            </a:r>
+          </a:p>
+          <a:p>
+            <a:pPr>
+              <a:spcAft>
+                <a:spcPts val="400"/>
+              </a:spcAft>
+              <a:defRPr sz="1200">
                 <a:solidFill>
                   <a:srgbClr val="6C757D"/>
                 </a:solidFill>
@@ -13059,12 +13060,12 @@
               </a:defRPr>
             </a:pPr>
             <a:r>
-              <a:t>選擇「New repository」（新增儲存庫）。</a:t>
-            </a:r>
-          </a:p>
-          <a:p>
-            <a:pPr>
-              <a:defRPr sz="1500" b="1">
+              <a:t>為防止密碼遭竊，GitHub 禁止終端機推播使用傳統密碼，必須改用 Personal Access Token (PAT)。</a:t>
+            </a:r>
+          </a:p>
+          <a:p>
+            <a:pPr>
+              <a:defRPr sz="1400" b="1">
                 <a:solidFill>
                   <a:srgbClr val="1F4435"/>
                 </a:solidFill>
@@ -13072,15 +13073,15 @@
               </a:defRPr>
             </a:pPr>
             <a:r>
-              <a:t>2. 輸入儲存庫名稱</a:t>
+              <a:t>1. 前往金鑰設定頁面</a:t>
             </a:r>
           </a:p>
           <a:p>
             <a:pPr>
               <a:spcAft>
-                <a:spcPts val="800"/>
+                <a:spcPts val="400"/>
               </a:spcAft>
-              <a:defRPr sz="1300">
+              <a:defRPr sz="1200">
                 <a:solidFill>
                   <a:srgbClr val="6C757D"/>
                 </a:solidFill>
@@ -13088,12 +13089,12 @@
               </a:defRPr>
             </a:pPr>
             <a:r>
-              <a:t>建議輸入英文字母，如 teacher-workshop 或 basic-circuits。</a:t>
-            </a:r>
-          </a:p>
-          <a:p>
-            <a:pPr>
-              <a:defRPr sz="1500" b="1">
+              <a:t>瀏覽器前往 github.com/settings/tokens，點 Generate new token (classic)。</a:t>
+            </a:r>
+          </a:p>
+          <a:p>
+            <a:pPr>
+              <a:defRPr sz="1400" b="1">
                 <a:solidFill>
                   <a:srgbClr val="1F4435"/>
                 </a:solidFill>
@@ -13101,15 +13102,15 @@
               </a:defRPr>
             </a:pPr>
             <a:r>
-              <a:t>3. 設為 Public（公開）</a:t>
+              <a:t>2. Note 填寫 antigravity</a:t>
             </a:r>
           </a:p>
           <a:p>
             <a:pPr>
               <a:spcAft>
-                <a:spcPts val="800"/>
+                <a:spcPts val="400"/>
               </a:spcAft>
-              <a:defRPr sz="1300">
+              <a:defRPr sz="1200">
                 <a:solidFill>
                   <a:srgbClr val="6C757D"/>
                 </a:solidFill>
@@ -13117,12 +13118,41 @@
               </a:defRPr>
             </a:pPr>
             <a:r>
-              <a:t>勾選 Public，其餘勾選項目保持預設免動。</a:t>
-            </a:r>
-          </a:p>
-          <a:p>
-            <a:pPr>
-              <a:defRPr sz="1500" b="1">
+              <a:t>有效期限選 No expiration 或 30 天。</a:t>
+            </a:r>
+          </a:p>
+          <a:p>
+            <a:pPr>
+              <a:defRPr sz="1400" b="1">
+                <a:solidFill>
+                  <a:srgbClr val="C25E2E"/>
+                </a:solidFill>
+                <a:latin typeface="微軟正黑體"/>
+              </a:defRPr>
+            </a:pPr>
+            <a:r>
+              <a:t>3. ⭐ 關鍵勾選 repo</a:t>
+            </a:r>
+          </a:p>
+          <a:p>
+            <a:pPr>
+              <a:spcAft>
+                <a:spcPts val="400"/>
+              </a:spcAft>
+              <a:defRPr sz="1200">
+                <a:solidFill>
+                  <a:srgbClr val="6C757D"/>
+                </a:solidFill>
+                <a:latin typeface="微軟正黑體"/>
+              </a:defRPr>
+            </a:pPr>
+            <a:r>
+              <a:t>請務必將第一個「repo」（倉庫完整存取）打勾！</a:t>
+            </a:r>
+          </a:p>
+          <a:p>
+            <a:pPr>
+              <a:defRPr sz="1400" b="1">
                 <a:solidFill>
                   <a:srgbClr val="1F4435"/>
                 </a:solidFill>
@@ -13130,15 +13160,15 @@
               </a:defRPr>
             </a:pPr>
             <a:r>
-              <a:t>4. 點擊綠色建立按鈕</a:t>
+              <a:t>4. 複製金鑰代碼</a:t>
             </a:r>
           </a:p>
           <a:p>
             <a:pPr>
               <a:spcAft>
-                <a:spcPts val="800"/>
+                <a:spcPts val="400"/>
               </a:spcAft>
-              <a:defRPr sz="1300">
+              <a:defRPr sz="1200">
                 <a:solidFill>
                   <a:srgbClr val="6C757D"/>
                 </a:solidFill>
@@ -13146,7 +13176,7 @@
               </a:defRPr>
             </a:pPr>
             <a:r>
-              <a:t>按下「Create repository」，複製網頁上顯示的網址（HTTPS）。</a:t>
+              <a:t>點擊最下方綠色按鈕，複製開頭為 ghp_ 的專屬權杖！</a:t>
             </a:r>
           </a:p>
         </p:txBody>
@@ -13220,9 +13250,9 @@
           <a:p>
             <a:pPr>
               <a:spcAft>
-                <a:spcPts val="800"/>
+                <a:spcPts val="1000"/>
               </a:spcAft>
-              <a:defRPr sz="2000" b="1">
+              <a:defRPr sz="1900" b="1">
                 <a:solidFill>
                   <a:srgbClr val="C25E2E"/>
                 </a:solidFill>
@@ -13230,29 +13260,26 @@
               </a:defRPr>
             </a:pPr>
             <a:r>
-              <a:t>📜 實戰提示詞 06：全自動網頁化與推送</a:t>
+              <a:t>🔒 資安第一：金鑰遮罩防洩漏守則</a:t>
+            </a:r>
+          </a:p>
+          <a:p>
+            <a:pPr>
+              <a:defRPr sz="1400" b="1">
+                <a:solidFill>
+                  <a:srgbClr val="BC4749"/>
+                </a:solidFill>
+                <a:latin typeface="微軟正黑體"/>
+              </a:defRPr>
+            </a:pPr>
+            <a:r>
+              <a:t>🚨 金鑰等同於您的臨時身分證！</a:t>
             </a:r>
           </a:p>
           <a:p>
             <a:pPr>
               <a:spcAft>
-                <a:spcPts val="400"/>
-              </a:spcAft>
-              <a:defRPr sz="1200" b="1">
-                <a:solidFill>
-                  <a:srgbClr val="C25E2E"/>
-                </a:solidFill>
-                <a:latin typeface="微軟正黑體"/>
-              </a:defRPr>
-            </a:pPr>
-            <a:r>
-              <a:t>💡 可直接反白複製使用：</a:t>
-            </a:r>
-          </a:p>
-          <a:p>
-            <a:pPr>
-              <a:spcAft>
-                <a:spcPts val="400"/>
+                <a:spcPts val="600"/>
               </a:spcAft>
               <a:defRPr sz="1200">
                 <a:solidFill>
@@ -13262,13 +13289,26 @@
               </a:defRPr>
             </a:pPr>
             <a:r>
-              <a:t>我已在 GitHub 建立好儲存庫，網址為 [貼上倉庫網址]。</a:t>
+              <a:t>任何人拿到您的 Token 都可以修改或覆寫您的雲端倉庫。</a:t>
+            </a:r>
+          </a:p>
+          <a:p>
+            <a:pPr>
+              <a:defRPr sz="1400" b="1">
+                <a:solidFill>
+                  <a:srgbClr val="1F4435"/>
+                </a:solidFill>
+                <a:latin typeface="微軟正黑體"/>
+              </a:defRPr>
+            </a:pPr>
+            <a:r>
+              <a:t>🙈 示範或講義中必須打馬賽克：</a:t>
             </a:r>
           </a:p>
           <a:p>
             <a:pPr>
               <a:spcAft>
-                <a:spcPts val="400"/>
+                <a:spcPts val="600"/>
               </a:spcAft>
               <a:defRPr sz="1200">
                 <a:solidFill>
@@ -13278,13 +13318,26 @@
               </a:defRPr>
             </a:pPr>
             <a:r>
-              <a:t>請幫我執行以下自動化動作鏈：</a:t>
+              <a:t>在簡報或公開錄影時，代碼必須做馬賽克遮罩處理：</a:t>
+            </a:r>
+          </a:p>
+          <a:p>
+            <a:pPr>
+              <a:defRPr sz="1400" b="1">
+                <a:solidFill>
+                  <a:srgbClr val="1F4435"/>
+                </a:solidFill>
+                <a:latin typeface="微軟正黑體"/>
+              </a:defRPr>
+            </a:pPr>
+            <a:r>
+              <a:t>   代碼示範：</a:t>
             </a:r>
           </a:p>
           <a:p>
             <a:pPr>
               <a:spcAft>
-                <a:spcPts val="400"/>
+                <a:spcPts val="600"/>
               </a:spcAft>
               <a:defRPr sz="1200">
                 <a:solidFill>
@@ -13294,13 +13347,26 @@
               </a:defRPr>
             </a:pPr>
             <a:r>
-              <a:t>1. 將今日的「基本電學題目與標準電路圖」自動轉成一個現代化響應式單頁網頁 (index.html)。</a:t>
+              <a:t>token = 'ghp_████████████████████████████████'</a:t>
+            </a:r>
+          </a:p>
+          <a:p>
+            <a:pPr>
+              <a:defRPr sz="1400" b="1">
+                <a:solidFill>
+                  <a:srgbClr val="1F4435"/>
+                </a:solidFill>
+                <a:latin typeface="微軟正黑體"/>
+              </a:defRPr>
+            </a:pPr>
+            <a:r>
+              <a:t>⚡ 代理人自動化驗證機制：</a:t>
             </a:r>
           </a:p>
           <a:p>
             <a:pPr>
               <a:spcAft>
-                <a:spcPts val="400"/>
+                <a:spcPts val="600"/>
               </a:spcAft>
               <a:defRPr sz="1200">
                 <a:solidFill>
@@ -13310,39 +13376,7 @@
               </a:defRPr>
             </a:pPr>
             <a:r>
-              <a:t>2. 將 Git 使用者綁定為我的姓名與 Email。</a:t>
-            </a:r>
-          </a:p>
-          <a:p>
-            <a:pPr>
-              <a:spcAft>
-                <a:spcPts val="400"/>
-              </a:spcAft>
-              <a:defRPr sz="1200">
-                <a:solidFill>
-                  <a:srgbClr val="2B2D42"/>
-                </a:solidFill>
-                <a:latin typeface="微軟正黑體"/>
-              </a:defRPr>
-            </a:pPr>
-            <a:r>
-              <a:t>3. 將 index.html、電路圖檔與投影片全部 commit 並 push 到該倉庫的 main 分支。</a:t>
-            </a:r>
-          </a:p>
-          <a:p>
-            <a:pPr>
-              <a:spcAft>
-                <a:spcPts val="400"/>
-              </a:spcAft>
-              <a:defRPr sz="1200">
-                <a:solidFill>
-                  <a:srgbClr val="2B2D42"/>
-                </a:solidFill>
-                <a:latin typeface="微軟正黑體"/>
-              </a:defRPr>
-            </a:pPr>
-            <a:r>
-              <a:t>4. 指引我到倉庫 Settings 開啟 GitHub Pages，並回報我最終的公開網站網址！</a:t>
+              <a:t>只要在當次對話中將 Token 提供給 Antigravity，代理人即自主完成 Git 身分驗證並推播，無需存留硬碟明文檔案！</a:t>
             </a:r>
           </a:p>
         </p:txBody>
@@ -13528,7 +13562,7 @@
               </a:defRPr>
             </a:pPr>
             <a:r>
-              <a:t>🌿 ANTIGRAVITY 研習手冊  |  研習總結</a:t>
+              <a:t>🌿 ANTIGRAVITY 研習手冊  |  單元四：成果網頁化與 GitHub 發布</a:t>
             </a:r>
           </a:p>
         </p:txBody>
@@ -13564,7 +13598,677 @@
               </a:defRPr>
             </a:pPr>
             <a:r>
-              <a:t>第 22 / 22 頁</a:t>
+              <a:t>第 22 / 23 頁</a:t>
+            </a:r>
+          </a:p>
+        </p:txBody>
+      </p:sp>
+      <p:sp>
+        <p:nvSpPr>
+          <p:cNvPr id="7" name="TextBox 6"/>
+          <p:cNvSpPr txBox="1"/>
+          <p:nvPr/>
+        </p:nvSpPr>
+        <p:spPr>
+          <a:xfrm>
+            <a:off x="731520" y="658368"/>
+            <a:ext cx="10698480" cy="685800"/>
+          </a:xfrm>
+          <a:prstGeom prst="rect">
+            <a:avLst/>
+          </a:prstGeom>
+          <a:noFill/>
+        </p:spPr>
+        <p:txBody>
+          <a:bodyPr wrap="square" lIns="0" tIns="0" rIns="0" bIns="0">
+            <a:spAutoFit/>
+          </a:bodyPr>
+          <a:lstStyle/>
+          <a:p>
+            <a:pPr>
+              <a:defRPr sz="2800" b="1">
+                <a:solidFill>
+                  <a:srgbClr val="1F4435"/>
+                </a:solidFill>
+                <a:latin typeface="微軟正黑體"/>
+              </a:defRPr>
+            </a:pPr>
+            <a:r>
+              <a:t>成果發布 03：代理人一鍵推播 ✕ GitHub Pages 上線 (Prompt 06)</a:t>
+            </a:r>
+          </a:p>
+        </p:txBody>
+      </p:sp>
+      <p:sp>
+        <p:nvSpPr>
+          <p:cNvPr id="8" name="Rounded Rectangle 7"/>
+          <p:cNvSpPr/>
+          <p:nvPr/>
+        </p:nvSpPr>
+        <p:spPr>
+          <a:xfrm>
+            <a:off x="731520" y="1645920"/>
+            <a:ext cx="5120640" cy="4389120"/>
+          </a:xfrm>
+          <a:prstGeom prst="roundRect">
+            <a:avLst/>
+          </a:prstGeom>
+          <a:solidFill>
+            <a:srgbClr val="FFFFFF"/>
+          </a:solidFill>
+          <a:ln w="19050">
+            <a:solidFill>
+              <a:srgbClr val="E6E0D6"/>
+            </a:solidFill>
+          </a:ln>
+        </p:spPr>
+        <p:style>
+          <a:lnRef idx="1">
+            <a:schemeClr val="accent1"/>
+          </a:lnRef>
+          <a:fillRef idx="3">
+            <a:schemeClr val="accent1"/>
+          </a:fillRef>
+          <a:effectRef idx="2">
+            <a:schemeClr val="accent1"/>
+          </a:effectRef>
+          <a:fontRef idx="minor">
+            <a:schemeClr val="lt1"/>
+          </a:fontRef>
+        </p:style>
+        <p:txBody>
+          <a:bodyPr rtlCol="0" anchor="ctr"/>
+          <a:lstStyle/>
+          <a:p>
+            <a:pPr algn="ctr"/>
+          </a:p>
+        </p:txBody>
+      </p:sp>
+      <p:sp>
+        <p:nvSpPr>
+          <p:cNvPr id="9" name="TextBox 8"/>
+          <p:cNvSpPr txBox="1"/>
+          <p:nvPr/>
+        </p:nvSpPr>
+        <p:spPr>
+          <a:xfrm>
+            <a:off x="1005840" y="1920240"/>
+            <a:ext cx="4572000" cy="3840480"/>
+          </a:xfrm>
+          <a:prstGeom prst="rect">
+            <a:avLst/>
+          </a:prstGeom>
+          <a:noFill/>
+        </p:spPr>
+        <p:txBody>
+          <a:bodyPr wrap="square">
+            <a:spAutoFit/>
+          </a:bodyPr>
+          <a:lstStyle/>
+          <a:p>
+            <a:pPr>
+              <a:spcAft>
+                <a:spcPts val="800"/>
+              </a:spcAft>
+              <a:defRPr sz="2000" b="1">
+                <a:solidFill>
+                  <a:srgbClr val="1F4435"/>
+                </a:solidFill>
+                <a:latin typeface="微軟正黑體"/>
+              </a:defRPr>
+            </a:pPr>
+            <a:r>
+              <a:t>📜 實戰提示詞 06：全自動推播咒語</a:t>
+            </a:r>
+          </a:p>
+          <a:p>
+            <a:pPr>
+              <a:spcAft>
+                <a:spcPts val="400"/>
+              </a:spcAft>
+              <a:defRPr sz="1200" b="1">
+                <a:solidFill>
+                  <a:srgbClr val="C25E2E"/>
+                </a:solidFill>
+                <a:latin typeface="微軟正黑體"/>
+              </a:defRPr>
+            </a:pPr>
+            <a:r>
+              <a:t>💡 可直接反白複製使用：</a:t>
+            </a:r>
+          </a:p>
+          <a:p>
+            <a:pPr>
+              <a:spcAft>
+                <a:spcPts val="400"/>
+              </a:spcAft>
+              <a:defRPr sz="1200">
+                <a:solidFill>
+                  <a:srgbClr val="2B2D42"/>
+                </a:solidFill>
+                <a:latin typeface="微軟正黑體"/>
+              </a:defRPr>
+            </a:pPr>
+            <a:r>
+              <a:t>我已在 GitHub 建立好公開儲存庫：https://github.com/stj580508/www，</a:t>
+            </a:r>
+          </a:p>
+          <a:p>
+            <a:pPr>
+              <a:spcAft>
+                <a:spcPts val="400"/>
+              </a:spcAft>
+              <a:defRPr sz="1200">
+                <a:solidFill>
+                  <a:srgbClr val="2B2D42"/>
+                </a:solidFill>
+                <a:latin typeface="微軟正黑體"/>
+              </a:defRPr>
+            </a:pPr>
+            <a:r>
+              <a:t>個人金鑰為 ghp_【貼上您的金鑰】。</a:t>
+            </a:r>
+          </a:p>
+          <a:p>
+            <a:pPr>
+              <a:spcAft>
+                <a:spcPts val="400"/>
+              </a:spcAft>
+              <a:defRPr sz="1200">
+                <a:solidFill>
+                  <a:srgbClr val="2B2D42"/>
+                </a:solidFill>
+                <a:latin typeface="微軟正黑體"/>
+              </a:defRPr>
+            </a:pPr>
+            <a:r>
+              <a:t>請幫我執行以下自動化連續動作鏈：</a:t>
+            </a:r>
+          </a:p>
+          <a:p>
+            <a:pPr>
+              <a:spcAft>
+                <a:spcPts val="400"/>
+              </a:spcAft>
+              <a:defRPr sz="1200">
+                <a:solidFill>
+                  <a:srgbClr val="2B2D42"/>
+                </a:solidFill>
+                <a:latin typeface="微軟正黑體"/>
+              </a:defRPr>
+            </a:pPr>
+            <a:r>
+              <a:t>1. 將今日的「基本電學題庫與標準電路圖」做成簡老師個人網站版面 (index.html)。</a:t>
+            </a:r>
+          </a:p>
+          <a:p>
+            <a:pPr>
+              <a:spcAft>
+                <a:spcPts val="400"/>
+              </a:spcAft>
+              <a:defRPr sz="1200">
+                <a:solidFill>
+                  <a:srgbClr val="2B2D42"/>
+                </a:solidFill>
+                <a:latin typeface="微軟正黑體"/>
+              </a:defRPr>
+            </a:pPr>
+            <a:r>
+              <a:t>2. 將 index.html、circuits/ 與 PPTX 投影片 Commit 並推播到 main 分支。</a:t>
+            </a:r>
+          </a:p>
+          <a:p>
+            <a:pPr>
+              <a:spcAft>
+                <a:spcPts val="400"/>
+              </a:spcAft>
+              <a:defRPr sz="1200">
+                <a:solidFill>
+                  <a:srgbClr val="2B2D42"/>
+                </a:solidFill>
+                <a:latin typeface="微軟正黑體"/>
+              </a:defRPr>
+            </a:pPr>
+            <a:r>
+              <a:t>3. 呼叫 GitHub API 為我啟用 GitHub Pages 靜態伺服器！</a:t>
+            </a:r>
+          </a:p>
+          <a:p>
+            <a:pPr>
+              <a:spcAft>
+                <a:spcPts val="400"/>
+              </a:spcAft>
+              <a:defRPr sz="1200">
+                <a:solidFill>
+                  <a:srgbClr val="2B2D42"/>
+                </a:solidFill>
+                <a:latin typeface="微軟正黑體"/>
+              </a:defRPr>
+            </a:pPr>
+            <a:r>
+              <a:t>4. 回報我最終公開上線的個人教學網站網址！</a:t>
+            </a:r>
+          </a:p>
+        </p:txBody>
+      </p:sp>
+      <p:sp>
+        <p:nvSpPr>
+          <p:cNvPr id="10" name="Rounded Rectangle 9"/>
+          <p:cNvSpPr/>
+          <p:nvPr/>
+        </p:nvSpPr>
+        <p:spPr>
+          <a:xfrm>
+            <a:off x="6309360" y="1645920"/>
+            <a:ext cx="5120640" cy="4389120"/>
+          </a:xfrm>
+          <a:prstGeom prst="roundRect">
+            <a:avLst/>
+          </a:prstGeom>
+          <a:solidFill>
+            <a:srgbClr val="FFFFFF"/>
+          </a:solidFill>
+          <a:ln w="19050">
+            <a:solidFill>
+              <a:srgbClr val="C25E2E"/>
+            </a:solidFill>
+          </a:ln>
+        </p:spPr>
+        <p:style>
+          <a:lnRef idx="1">
+            <a:schemeClr val="accent1"/>
+          </a:lnRef>
+          <a:fillRef idx="3">
+            <a:schemeClr val="accent1"/>
+          </a:fillRef>
+          <a:effectRef idx="2">
+            <a:schemeClr val="accent1"/>
+          </a:effectRef>
+          <a:fontRef idx="minor">
+            <a:schemeClr val="lt1"/>
+          </a:fontRef>
+        </p:style>
+        <p:txBody>
+          <a:bodyPr rtlCol="0" anchor="ctr"/>
+          <a:lstStyle/>
+          <a:p>
+            <a:pPr algn="ctr"/>
+          </a:p>
+        </p:txBody>
+      </p:sp>
+      <p:sp>
+        <p:nvSpPr>
+          <p:cNvPr id="11" name="TextBox 10"/>
+          <p:cNvSpPr txBox="1"/>
+          <p:nvPr/>
+        </p:nvSpPr>
+        <p:spPr>
+          <a:xfrm>
+            <a:off x="6583680" y="1920240"/>
+            <a:ext cx="4572000" cy="3840480"/>
+          </a:xfrm>
+          <a:prstGeom prst="rect">
+            <a:avLst/>
+          </a:prstGeom>
+          <a:noFill/>
+        </p:spPr>
+        <p:txBody>
+          <a:bodyPr wrap="square">
+            <a:spAutoFit/>
+          </a:bodyPr>
+          <a:lstStyle/>
+          <a:p>
+            <a:pPr>
+              <a:spcAft>
+                <a:spcPts val="1000"/>
+              </a:spcAft>
+              <a:defRPr sz="1900" b="1">
+                <a:solidFill>
+                  <a:srgbClr val="C25E2E"/>
+                </a:solidFill>
+                <a:latin typeface="微軟正黑體"/>
+              </a:defRPr>
+            </a:pPr>
+            <a:r>
+              <a:t>🎉 成果大功告成：全世界隨點隨看！</a:t>
+            </a:r>
+          </a:p>
+          <a:p>
+            <a:pPr>
+              <a:defRPr sz="1400" b="1">
+                <a:solidFill>
+                  <a:srgbClr val="1F4435"/>
+                </a:solidFill>
+                <a:latin typeface="微軟正黑體"/>
+              </a:defRPr>
+            </a:pPr>
+            <a:r>
+              <a:t>🌐 官方專屬上線網址：</a:t>
+            </a:r>
+          </a:p>
+          <a:p>
+            <a:pPr>
+              <a:spcAft>
+                <a:spcPts val="600"/>
+              </a:spcAft>
+              <a:defRPr sz="1200">
+                <a:solidFill>
+                  <a:srgbClr val="2B2D42"/>
+                </a:solidFill>
+                <a:latin typeface="微軟正黑體"/>
+              </a:defRPr>
+            </a:pPr>
+            <a:r>
+              <a:t>👉 https://stj580508.github.io/www/</a:t>
+            </a:r>
+          </a:p>
+          <a:p>
+            <a:pPr>
+              <a:defRPr sz="1400" b="1">
+                <a:solidFill>
+                  <a:srgbClr val="1F4435"/>
+                </a:solidFill>
+                <a:latin typeface="微軟正黑體"/>
+              </a:defRPr>
+            </a:pPr>
+            <a:r>
+              <a:t>📘 專屬教學專頁已上線：</a:t>
+            </a:r>
+          </a:p>
+          <a:p>
+            <a:pPr>
+              <a:spcAft>
+                <a:spcPts val="600"/>
+              </a:spcAft>
+              <a:defRPr sz="1200">
+                <a:solidFill>
+                  <a:srgbClr val="2B2D42"/>
+                </a:solidFill>
+                <a:latin typeface="微軟正黑體"/>
+              </a:defRPr>
+            </a:pPr>
+            <a:r>
+              <a:t>👉 https://stj580508.github.io/www/github_tutorial.html</a:t>
+            </a:r>
+          </a:p>
+          <a:p>
+            <a:pPr>
+              <a:defRPr sz="1400" b="1">
+                <a:solidFill>
+                  <a:srgbClr val="1F4435"/>
+                </a:solidFill>
+                <a:latin typeface="微軟正黑體"/>
+              </a:defRPr>
+            </a:pPr>
+            <a:r>
+              <a:t>📱 行動學習亮點：</a:t>
+            </a:r>
+          </a:p>
+          <a:p>
+            <a:pPr>
+              <a:spcAft>
+                <a:spcPts val="600"/>
+              </a:spcAft>
+              <a:defRPr sz="1200">
+                <a:solidFill>
+                  <a:srgbClr val="2B2D42"/>
+                </a:solidFill>
+                <a:latin typeface="微軟正黑體"/>
+              </a:defRPr>
+            </a:pPr>
+            <a:r>
+              <a:t>無論用手機、平板或智慧黑板，掃描 QR Code 就能即時檢視互動題庫與標準電路圖！</a:t>
+            </a:r>
+          </a:p>
+          <a:p>
+            <a:pPr>
+              <a:defRPr sz="1400" b="1">
+                <a:solidFill>
+                  <a:srgbClr val="1F4435"/>
+                </a:solidFill>
+                <a:latin typeface="微軟正黑體"/>
+              </a:defRPr>
+            </a:pPr>
+            <a:r>
+              <a:t>⚡ 代理 AI 革命性價值：</a:t>
+            </a:r>
+          </a:p>
+          <a:p>
+            <a:pPr>
+              <a:spcAft>
+                <a:spcPts val="600"/>
+              </a:spcAft>
+              <a:defRPr sz="1200">
+                <a:solidFill>
+                  <a:srgbClr val="2B2D42"/>
+                </a:solidFill>
+                <a:latin typeface="微軟正黑體"/>
+              </a:defRPr>
+            </a:pPr>
+            <a:r>
+              <a:t>老師完全不用敲複雜終端機指令，自然語言即可完成「備課 ➔ 出題 ➔ 繪圖 ➔ 網頁化 ➔ 雲端發布」一條龍！</a:t>
+            </a:r>
+          </a:p>
+        </p:txBody>
+      </p:sp>
+    </p:spTree>
+  </p:cSld>
+  <p:clrMapOvr>
+    <a:masterClrMapping/>
+  </p:clrMapOvr>
+  <p:transition spd="med">
+    <p:fade/>
+  </p:transition>
+</p:sld>
+</file>
+
+<file path=ppt/slides/slide23.xml><?xml version="1.0" encoding="utf-8"?>
+<p:sld xmlns:a="http://schemas.openxmlformats.org/drawingml/2006/main" xmlns:p="http://schemas.openxmlformats.org/presentationml/2006/main" xmlns:r="http://schemas.openxmlformats.org/officeDocument/2006/relationships">
+  <p:cSld>
+    <p:spTree>
+      <p:nvGrpSpPr>
+        <p:cNvPr id="1" name=""/>
+        <p:cNvGrpSpPr/>
+        <p:nvPr/>
+      </p:nvGrpSpPr>
+      <p:grpSpPr/>
+      <p:sp>
+        <p:nvSpPr>
+          <p:cNvPr id="2" name="Rectangle 1"/>
+          <p:cNvSpPr/>
+          <p:nvPr/>
+        </p:nvSpPr>
+        <p:spPr>
+          <a:xfrm>
+            <a:off x="0" y="0"/>
+            <a:ext cx="12191695" cy="6858000"/>
+          </a:xfrm>
+          <a:prstGeom prst="rect">
+            <a:avLst/>
+          </a:prstGeom>
+          <a:solidFill>
+            <a:srgbClr val="FAF7F2"/>
+          </a:solidFill>
+          <a:ln>
+            <a:noFill/>
+          </a:ln>
+        </p:spPr>
+        <p:style>
+          <a:lnRef idx="1">
+            <a:schemeClr val="accent1"/>
+          </a:lnRef>
+          <a:fillRef idx="3">
+            <a:schemeClr val="accent1"/>
+          </a:fillRef>
+          <a:effectRef idx="2">
+            <a:schemeClr val="accent1"/>
+          </a:effectRef>
+          <a:fontRef idx="minor">
+            <a:schemeClr val="lt1"/>
+          </a:fontRef>
+        </p:style>
+        <p:txBody>
+          <a:bodyPr rtlCol="0" anchor="ctr"/>
+          <a:lstStyle/>
+          <a:p>
+            <a:pPr algn="ctr"/>
+          </a:p>
+        </p:txBody>
+      </p:sp>
+      <p:sp>
+        <p:nvSpPr>
+          <p:cNvPr id="3" name="Rectangle 2"/>
+          <p:cNvSpPr/>
+          <p:nvPr/>
+        </p:nvSpPr>
+        <p:spPr>
+          <a:xfrm>
+            <a:off x="0" y="0"/>
+            <a:ext cx="12191695" cy="109728"/>
+          </a:xfrm>
+          <a:prstGeom prst="rect">
+            <a:avLst/>
+          </a:prstGeom>
+          <a:solidFill>
+            <a:srgbClr val="1F4435"/>
+          </a:solidFill>
+          <a:ln>
+            <a:noFill/>
+          </a:ln>
+        </p:spPr>
+        <p:style>
+          <a:lnRef idx="1">
+            <a:schemeClr val="accent1"/>
+          </a:lnRef>
+          <a:fillRef idx="3">
+            <a:schemeClr val="accent1"/>
+          </a:fillRef>
+          <a:effectRef idx="2">
+            <a:schemeClr val="accent1"/>
+          </a:effectRef>
+          <a:fontRef idx="minor">
+            <a:schemeClr val="lt1"/>
+          </a:fontRef>
+        </p:style>
+        <p:txBody>
+          <a:bodyPr rtlCol="0" anchor="ctr"/>
+          <a:lstStyle/>
+          <a:p>
+            <a:pPr algn="ctr"/>
+          </a:p>
+        </p:txBody>
+      </p:sp>
+      <p:sp>
+        <p:nvSpPr>
+          <p:cNvPr id="4" name="Rectangle 3"/>
+          <p:cNvSpPr/>
+          <p:nvPr/>
+        </p:nvSpPr>
+        <p:spPr>
+          <a:xfrm>
+            <a:off x="0" y="109728"/>
+            <a:ext cx="3840480" cy="36576"/>
+          </a:xfrm>
+          <a:prstGeom prst="rect">
+            <a:avLst/>
+          </a:prstGeom>
+          <a:solidFill>
+            <a:srgbClr val="C25E2E"/>
+          </a:solidFill>
+          <a:ln>
+            <a:noFill/>
+          </a:ln>
+        </p:spPr>
+        <p:style>
+          <a:lnRef idx="1">
+            <a:schemeClr val="accent1"/>
+          </a:lnRef>
+          <a:fillRef idx="3">
+            <a:schemeClr val="accent1"/>
+          </a:fillRef>
+          <a:effectRef idx="2">
+            <a:schemeClr val="accent1"/>
+          </a:effectRef>
+          <a:fontRef idx="minor">
+            <a:schemeClr val="lt1"/>
+          </a:fontRef>
+        </p:style>
+        <p:txBody>
+          <a:bodyPr rtlCol="0" anchor="ctr"/>
+          <a:lstStyle/>
+          <a:p>
+            <a:pPr algn="ctr"/>
+          </a:p>
+        </p:txBody>
+      </p:sp>
+      <p:sp>
+        <p:nvSpPr>
+          <p:cNvPr id="5" name="TextBox 4"/>
+          <p:cNvSpPr txBox="1"/>
+          <p:nvPr/>
+        </p:nvSpPr>
+        <p:spPr>
+          <a:xfrm>
+            <a:off x="731520" y="320040"/>
+            <a:ext cx="7772400" cy="320040"/>
+          </a:xfrm>
+          <a:prstGeom prst="rect">
+            <a:avLst/>
+          </a:prstGeom>
+          <a:noFill/>
+        </p:spPr>
+        <p:txBody>
+          <a:bodyPr wrap="none" lIns="0" tIns="0" rIns="0" bIns="0">
+            <a:spAutoFit/>
+          </a:bodyPr>
+          <a:lstStyle/>
+          <a:p>
+            <a:pPr>
+              <a:defRPr sz="1300" b="1">
+                <a:solidFill>
+                  <a:srgbClr val="C25E2E"/>
+                </a:solidFill>
+                <a:latin typeface="微軟正黑體"/>
+              </a:defRPr>
+            </a:pPr>
+            <a:r>
+              <a:t>🌿 ANTIGRAVITY 研習手冊  |  研習總結</a:t>
+            </a:r>
+          </a:p>
+        </p:txBody>
+      </p:sp>
+      <p:sp>
+        <p:nvSpPr>
+          <p:cNvPr id="6" name="TextBox 5"/>
+          <p:cNvSpPr txBox="1"/>
+          <p:nvPr/>
+        </p:nvSpPr>
+        <p:spPr>
+          <a:xfrm>
+            <a:off x="9326880" y="320040"/>
+            <a:ext cx="2103120" cy="320040"/>
+          </a:xfrm>
+          <a:prstGeom prst="rect">
+            <a:avLst/>
+          </a:prstGeom>
+          <a:noFill/>
+        </p:spPr>
+        <p:txBody>
+          <a:bodyPr wrap="none" lIns="0" tIns="0" rIns="0" bIns="0">
+            <a:spAutoFit/>
+          </a:bodyPr>
+          <a:lstStyle/>
+          <a:p>
+            <a:pPr algn="r">
+              <a:defRPr sz="1300">
+                <a:solidFill>
+                  <a:srgbClr val="6C757D"/>
+                </a:solidFill>
+                <a:latin typeface="微軟正黑體"/>
+              </a:defRPr>
+            </a:pPr>
+            <a:r>
+              <a:t>第 23 / 23 頁</a:t>
             </a:r>
           </a:p>
         </p:txBody>
@@ -14166,7 +14870,7 @@
               </a:defRPr>
             </a:pPr>
             <a:r>
-              <a:t>第 03 / 22 頁</a:t>
+              <a:t>第 03 / 23 頁</a:t>
             </a:r>
           </a:p>
         </p:txBody>
@@ -14877,7 +15581,7 @@
               </a:defRPr>
             </a:pPr>
             <a:r>
-              <a:t>第 04 / 22 頁</a:t>
+              <a:t>第 04 / 23 頁</a:t>
             </a:r>
           </a:p>
         </p:txBody>
@@ -15463,7 +16167,7 @@
               </a:defRPr>
             </a:pPr>
             <a:r>
-              <a:t>第 05 / 22 頁</a:t>
+              <a:t>第 05 / 23 頁</a:t>
             </a:r>
           </a:p>
         </p:txBody>
@@ -16228,7 +16932,7 @@
               </a:defRPr>
             </a:pPr>
             <a:r>
-              <a:t>第 06 / 22 頁</a:t>
+              <a:t>第 06 / 23 頁</a:t>
             </a:r>
           </a:p>
         </p:txBody>
@@ -16786,7 +17490,7 @@
               </a:defRPr>
             </a:pPr>
             <a:r>
-              <a:t>第 07 / 22 頁</a:t>
+              <a:t>第 07 / 23 頁</a:t>
             </a:r>
           </a:p>
         </p:txBody>
@@ -17224,7 +17928,7 @@
               </a:defRPr>
             </a:pPr>
             <a:r>
-              <a:t>第 08 / 22 頁</a:t>
+              <a:t>第 08 / 23 頁</a:t>
             </a:r>
           </a:p>
         </p:txBody>
@@ -17993,7 +18697,7 @@
               </a:defRPr>
             </a:pPr>
             <a:r>
-              <a:t>第 09 / 22 頁</a:t>
+              <a:t>第 09 / 23 頁</a:t>
             </a:r>
           </a:p>
         </p:txBody>

</xml_diff>